<commit_message>
Siste oppdatering før jeg leverer prosjektet.
</commit_message>
<xml_diff>
--- a/Vedlegg 4 - Presentasjon/Sikker kommunikasjon i byggautomasjon med Tailscale og OPC.pptx
+++ b/Vedlegg 4 - Presentasjon/Sikker kommunikasjon i byggautomasjon med Tailscale og OPC.pptx
@@ -246,7 +246,7 @@
           <a:p>
             <a:fld id="{5FE1BD91-224E-46EE-B309-5872AF7BDDF5}" type="datetimeFigureOut">
               <a:rPr lang="nb-NO" smtClean="0"/>
-              <a:t>17.04.2025</a:t>
+              <a:t>18.05.2025</a:t>
             </a:fld>
             <a:endParaRPr lang="nb-NO"/>
           </a:p>
@@ -831,7 +831,7 @@
           <a:p>
             <a:fld id="{879D1FD7-5C7A-4C36-A7F8-B923B96AD6A9}" type="datetimeFigureOut">
               <a:rPr lang="nb-NO" smtClean="0"/>
-              <a:t>17.04.2025</a:t>
+              <a:t>18.05.2025</a:t>
             </a:fld>
             <a:endParaRPr lang="nb-NO"/>
           </a:p>
@@ -1031,7 +1031,7 @@
           <a:p>
             <a:fld id="{879D1FD7-5C7A-4C36-A7F8-B923B96AD6A9}" type="datetimeFigureOut">
               <a:rPr lang="nb-NO" smtClean="0"/>
-              <a:t>17.04.2025</a:t>
+              <a:t>18.05.2025</a:t>
             </a:fld>
             <a:endParaRPr lang="nb-NO"/>
           </a:p>
@@ -1241,7 +1241,7 @@
           <a:p>
             <a:fld id="{879D1FD7-5C7A-4C36-A7F8-B923B96AD6A9}" type="datetimeFigureOut">
               <a:rPr lang="nb-NO" smtClean="0"/>
-              <a:t>17.04.2025</a:t>
+              <a:t>18.05.2025</a:t>
             </a:fld>
             <a:endParaRPr lang="nb-NO"/>
           </a:p>
@@ -1441,7 +1441,7 @@
           <a:p>
             <a:fld id="{879D1FD7-5C7A-4C36-A7F8-B923B96AD6A9}" type="datetimeFigureOut">
               <a:rPr lang="nb-NO" smtClean="0"/>
-              <a:t>17.04.2025</a:t>
+              <a:t>18.05.2025</a:t>
             </a:fld>
             <a:endParaRPr lang="nb-NO"/>
           </a:p>
@@ -1717,7 +1717,7 @@
           <a:p>
             <a:fld id="{879D1FD7-5C7A-4C36-A7F8-B923B96AD6A9}" type="datetimeFigureOut">
               <a:rPr lang="nb-NO" smtClean="0"/>
-              <a:t>17.04.2025</a:t>
+              <a:t>18.05.2025</a:t>
             </a:fld>
             <a:endParaRPr lang="nb-NO"/>
           </a:p>
@@ -1985,7 +1985,7 @@
           <a:p>
             <a:fld id="{879D1FD7-5C7A-4C36-A7F8-B923B96AD6A9}" type="datetimeFigureOut">
               <a:rPr lang="nb-NO" smtClean="0"/>
-              <a:t>17.04.2025</a:t>
+              <a:t>18.05.2025</a:t>
             </a:fld>
             <a:endParaRPr lang="nb-NO"/>
           </a:p>
@@ -2400,7 +2400,7 @@
           <a:p>
             <a:fld id="{879D1FD7-5C7A-4C36-A7F8-B923B96AD6A9}" type="datetimeFigureOut">
               <a:rPr lang="nb-NO" smtClean="0"/>
-              <a:t>17.04.2025</a:t>
+              <a:t>18.05.2025</a:t>
             </a:fld>
             <a:endParaRPr lang="nb-NO"/>
           </a:p>
@@ -2542,7 +2542,7 @@
           <a:p>
             <a:fld id="{879D1FD7-5C7A-4C36-A7F8-B923B96AD6A9}" type="datetimeFigureOut">
               <a:rPr lang="nb-NO" smtClean="0"/>
-              <a:t>17.04.2025</a:t>
+              <a:t>18.05.2025</a:t>
             </a:fld>
             <a:endParaRPr lang="nb-NO"/>
           </a:p>
@@ -2655,7 +2655,7 @@
           <a:p>
             <a:fld id="{879D1FD7-5C7A-4C36-A7F8-B923B96AD6A9}" type="datetimeFigureOut">
               <a:rPr lang="nb-NO" smtClean="0"/>
-              <a:t>17.04.2025</a:t>
+              <a:t>18.05.2025</a:t>
             </a:fld>
             <a:endParaRPr lang="nb-NO"/>
           </a:p>
@@ -2968,7 +2968,7 @@
           <a:p>
             <a:fld id="{879D1FD7-5C7A-4C36-A7F8-B923B96AD6A9}" type="datetimeFigureOut">
               <a:rPr lang="nb-NO" smtClean="0"/>
-              <a:t>17.04.2025</a:t>
+              <a:t>18.05.2025</a:t>
             </a:fld>
             <a:endParaRPr lang="nb-NO"/>
           </a:p>
@@ -3257,7 +3257,7 @@
           <a:p>
             <a:fld id="{879D1FD7-5C7A-4C36-A7F8-B923B96AD6A9}" type="datetimeFigureOut">
               <a:rPr lang="nb-NO" smtClean="0"/>
-              <a:t>17.04.2025</a:t>
+              <a:t>18.05.2025</a:t>
             </a:fld>
             <a:endParaRPr lang="nb-NO"/>
           </a:p>
@@ -3530,7 +3530,7 @@
           <a:p>
             <a:fld id="{879D1FD7-5C7A-4C36-A7F8-B923B96AD6A9}" type="datetimeFigureOut">
               <a:rPr lang="nb-NO" smtClean="0"/>
-              <a:t>17.04.2025</a:t>
+              <a:t>18.05.2025</a:t>
             </a:fld>
             <a:endParaRPr lang="nb-NO"/>
           </a:p>

</xml_diff>